<commit_message>
Lecture 2, 8-25-26 added, Good Exit Ticket Answers added
</commit_message>
<xml_diff>
--- a/python/CourseDesign/Week01e/Week1_Lecture2_Eigenfunctions_DTFT.pptx
+++ b/python/CourseDesign/Week01e/Week1_Lecture2_Eigenfunctions_DTFT.pptx
@@ -5,7 +5,7 @@
     <p:sldMasterId id="2147483648" r:id="rId1"/>
   </p:sldMasterIdLst>
   <p:notesMasterIdLst>
-    <p:notesMasterId r:id="rId24"/>
+    <p:notesMasterId r:id="rId25"/>
   </p:notesMasterIdLst>
   <p:sldIdLst>
     <p:sldId id="256" r:id="rId2"/>
@@ -28,8 +28,9 @@
     <p:sldId id="273" r:id="rId19"/>
     <p:sldId id="274" r:id="rId20"/>
     <p:sldId id="275" r:id="rId21"/>
-    <p:sldId id="276" r:id="rId22"/>
-    <p:sldId id="277" r:id="rId23"/>
+    <p:sldId id="278" r:id="rId22"/>
+    <p:sldId id="276" r:id="rId23"/>
+    <p:sldId id="277" r:id="rId24"/>
   </p:sldIdLst>
   <p:sldSz cx="12192000" cy="6858000"/>
   <p:notesSz cx="6858000" cy="12192000"/>
@@ -1724,7 +1725,13 @@
   <p:cSld>
     <p:spTree>
       <p:nvGrpSpPr>
-        <p:cNvPr id="1" name=""/>
+        <p:cNvPr id="1" name="">
+          <a:extLst>
+            <a:ext uri="{FF2B5EF4-FFF2-40B4-BE49-F238E27FC236}">
+              <a16:creationId xmlns:a16="http://schemas.microsoft.com/office/drawing/2014/main" id="{AAF8F7B2-56CD-306F-9C11-244E335CD496}"/>
+            </a:ext>
+          </a:extLst>
+        </p:cNvPr>
         <p:cNvGrpSpPr/>
         <p:nvPr/>
       </p:nvGrpSpPr>
@@ -1738,7 +1745,13 @@
       </p:grpSpPr>
       <p:sp>
         <p:nvSpPr>
-          <p:cNvPr id="2" name="Slide Image Placeholder 1"/>
+          <p:cNvPr id="2" name="Slide Image Placeholder 1">
+            <a:extLst>
+              <a:ext uri="{FF2B5EF4-FFF2-40B4-BE49-F238E27FC236}">
+                <a16:creationId xmlns:a16="http://schemas.microsoft.com/office/drawing/2014/main" id="{854B41DF-4106-63C2-64AA-3988D27A258D}"/>
+              </a:ext>
+            </a:extLst>
+          </p:cNvPr>
           <p:cNvSpPr>
             <a:spLocks noGrp="1" noRot="1" noChangeAspect="1"/>
           </p:cNvSpPr>
@@ -1750,7 +1763,13 @@
       </p:sp>
       <p:sp>
         <p:nvSpPr>
-          <p:cNvPr id="3" name="Notes Placeholder 2"/>
+          <p:cNvPr id="3" name="Notes Placeholder 2">
+            <a:extLst>
+              <a:ext uri="{FF2B5EF4-FFF2-40B4-BE49-F238E27FC236}">
+                <a16:creationId xmlns:a16="http://schemas.microsoft.com/office/drawing/2014/main" id="{AED8A5A0-A762-9034-0504-F7167B157492}"/>
+              </a:ext>
+            </a:extLst>
+          </p:cNvPr>
           <p:cNvSpPr>
             <a:spLocks noGrp="1"/>
           </p:cNvSpPr>
@@ -1765,15 +1784,21 @@
           <a:p>
             <a:r>
               <a:rPr lang="en-US" dirty="0"/>
-              <a:t>Timing: 3 min.
-Exit ticket: “Why can an LTI system change the amplitude and phase of a sinusoid but not its frequency?”</a:t>
-            </a:r>
-          </a:p>
-        </p:txBody>
-      </p:sp>
-      <p:sp>
-        <p:nvSpPr>
-          <p:cNvPr id="4" name="Slide Number Placeholder 3"/>
+              <a:t>Timing: 2 min.
+Correct answer A.</a:t>
+            </a:r>
+          </a:p>
+        </p:txBody>
+      </p:sp>
+      <p:sp>
+        <p:nvSpPr>
+          <p:cNvPr id="4" name="Slide Number Placeholder 3">
+            <a:extLst>
+              <a:ext uri="{FF2B5EF4-FFF2-40B4-BE49-F238E27FC236}">
+                <a16:creationId xmlns:a16="http://schemas.microsoft.com/office/drawing/2014/main" id="{4977E9C9-0680-356B-8090-C7B68E8A025B}"/>
+              </a:ext>
+            </a:extLst>
+          </p:cNvPr>
           <p:cNvSpPr>
             <a:spLocks noGrp="1"/>
           </p:cNvSpPr>
@@ -1797,7 +1822,7 @@
     </p:spTree>
     <p:extLst>
       <p:ext uri="{BB962C8B-B14F-4D97-AF65-F5344CB8AC3E}">
-        <p14:creationId xmlns:p14="http://schemas.microsoft.com/office/powerpoint/2010/main" val="1024086991"/>
+        <p14:creationId xmlns:p14="http://schemas.microsoft.com/office/powerpoint/2010/main" val="3932483414"/>
       </p:ext>
     </p:extLst>
   </p:cSld>
@@ -1853,7 +1878,8 @@
           <a:p>
             <a:r>
               <a:rPr lang="en-US" dirty="0"/>
-              <a:t>If the Think-Pair-Share runs long, move the quiz to the start of Week 2.</a:t>
+              <a:t>Timing: 3 min.
+Exit ticket: “Why can an LTI system change the amplitude and phase of a sinusoid but not its frequency?”</a:t>
             </a:r>
           </a:p>
         </p:txBody>
@@ -1876,6 +1902,93 @@
             <a:fld id="{F7021451-1387-4CA6-816F-3879F97B5CBC}" type="slidenum">
               <a:rPr lang="en-US"/>
               <a:t>22</a:t>
+            </a:fld>
+            <a:endParaRPr lang="en-US"/>
+          </a:p>
+        </p:txBody>
+      </p:sp>
+    </p:spTree>
+    <p:extLst>
+      <p:ext uri="{BB962C8B-B14F-4D97-AF65-F5344CB8AC3E}">
+        <p14:creationId xmlns:p14="http://schemas.microsoft.com/office/powerpoint/2010/main" val="1024086991"/>
+      </p:ext>
+    </p:extLst>
+  </p:cSld>
+  <p:clrMapOvr>
+    <a:masterClrMapping/>
+  </p:clrMapOvr>
+</p:notes>
+</file>
+
+<file path=ppt/notesSlides/notesSlide23.xml><?xml version="1.0" encoding="utf-8"?>
+<p:notes xmlns:a="http://schemas.openxmlformats.org/drawingml/2006/main" xmlns:r="http://schemas.openxmlformats.org/officeDocument/2006/relationships" xmlns:p="http://schemas.openxmlformats.org/presentationml/2006/main">
+  <p:cSld>
+    <p:spTree>
+      <p:nvGrpSpPr>
+        <p:cNvPr id="1" name=""/>
+        <p:cNvGrpSpPr/>
+        <p:nvPr/>
+      </p:nvGrpSpPr>
+      <p:grpSpPr>
+        <a:xfrm>
+          <a:off x="0" y="0"/>
+          <a:ext cx="0" cy="0"/>
+          <a:chOff x="0" y="0"/>
+          <a:chExt cx="0" cy="0"/>
+        </a:xfrm>
+      </p:grpSpPr>
+      <p:sp>
+        <p:nvSpPr>
+          <p:cNvPr id="2" name="Slide Image Placeholder 1"/>
+          <p:cNvSpPr>
+            <a:spLocks noGrp="1" noRot="1" noChangeAspect="1"/>
+          </p:cNvSpPr>
+          <p:nvPr>
+            <p:ph type="sldImg"/>
+          </p:nvPr>
+        </p:nvSpPr>
+        <p:spPr/>
+      </p:sp>
+      <p:sp>
+        <p:nvSpPr>
+          <p:cNvPr id="3" name="Notes Placeholder 2"/>
+          <p:cNvSpPr>
+            <a:spLocks noGrp="1"/>
+          </p:cNvSpPr>
+          <p:nvPr>
+            <p:ph type="body" idx="1"/>
+          </p:nvPr>
+        </p:nvSpPr>
+        <p:spPr/>
+        <p:txBody>
+          <a:bodyPr/>
+          <a:lstStyle/>
+          <a:p>
+            <a:r>
+              <a:rPr lang="en-US" dirty="0"/>
+              <a:t>If the Think-Pair-Share runs long, move the quiz to the start of Week 2.</a:t>
+            </a:r>
+          </a:p>
+        </p:txBody>
+      </p:sp>
+      <p:sp>
+        <p:nvSpPr>
+          <p:cNvPr id="4" name="Slide Number Placeholder 3"/>
+          <p:cNvSpPr>
+            <a:spLocks noGrp="1"/>
+          </p:cNvSpPr>
+          <p:nvPr>
+            <p:ph type="sldNum" sz="quarter" idx="10"/>
+          </p:nvPr>
+        </p:nvSpPr>
+        <p:spPr/>
+        <p:txBody>
+          <a:bodyPr/>
+          <a:lstStyle/>
+          <a:p>
+            <a:fld id="{F7021451-1387-4CA6-816F-3879F97B5CBC}" type="slidenum">
+              <a:rPr lang="en-US"/>
+              <a:t>23</a:t>
             </a:fld>
             <a:endParaRPr lang="en-US"/>
           </a:p>
@@ -6295,7 +6408,7 @@
         </p:blipFill>
         <p:spPr>
           <a:xfrm>
-            <a:off x="6309360" y="1188720"/>
+            <a:off x="6565392" y="1688374"/>
             <a:ext cx="5029200" cy="914400"/>
           </a:xfrm>
           <a:prstGeom prst="rect">
@@ -10648,6 +10761,46 @@
       </p:grpSpPr>
       <p:sp>
         <p:nvSpPr>
+          <p:cNvPr id="17" name="Shape 7">
+            <a:extLst>
+              <a:ext uri="{FF2B5EF4-FFF2-40B4-BE49-F238E27FC236}">
+                <a16:creationId xmlns:a16="http://schemas.microsoft.com/office/drawing/2014/main" id="{B9318643-0B8D-601F-B2D7-342CAB094A78}"/>
+              </a:ext>
+            </a:extLst>
+          </p:cNvPr>
+          <p:cNvSpPr/>
+          <p:nvPr/>
+        </p:nvSpPr>
+        <p:spPr>
+          <a:xfrm>
+            <a:off x="960120" y="2221992"/>
+            <a:ext cx="10195560" cy="502920"/>
+          </a:xfrm>
+          <a:prstGeom prst="roundRect">
+            <a:avLst>
+              <a:gd name="adj" fmla="val 7273"/>
+            </a:avLst>
+          </a:prstGeom>
+          <a:solidFill>
+            <a:srgbClr val="F4F7FA"/>
+          </a:solidFill>
+          <a:ln w="12700">
+            <a:solidFill>
+              <a:srgbClr val="DCE4EA"/>
+            </a:solidFill>
+            <a:prstDash val="solid"/>
+          </a:ln>
+        </p:spPr>
+        <p:txBody>
+          <a:bodyPr/>
+          <a:lstStyle/>
+          <a:p>
+            <a:endParaRPr lang="en-US"/>
+          </a:p>
+        </p:txBody>
+      </p:sp>
+      <p:sp>
+        <p:nvSpPr>
           <p:cNvPr id="2" name="Text 0"/>
           <p:cNvSpPr/>
           <p:nvPr/>
@@ -10831,7 +10984,551 @@
       </p:sp>
       <p:sp>
         <p:nvSpPr>
-          <p:cNvPr id="7" name="Shape 5"/>
+          <p:cNvPr id="8" name="Text 6"/>
+          <p:cNvSpPr/>
+          <p:nvPr/>
+        </p:nvSpPr>
+        <p:spPr>
+          <a:xfrm>
+            <a:off x="1133856" y="2368296"/>
+            <a:ext cx="9738360" cy="219456"/>
+          </a:xfrm>
+          <a:prstGeom prst="rect">
+            <a:avLst/>
+          </a:prstGeom>
+          <a:noFill/>
+          <a:ln/>
+        </p:spPr>
+        <p:txBody>
+          <a:bodyPr wrap="square" lIns="0" tIns="0" rIns="0" bIns="0" rtlCol="0" anchor="ctr"/>
+          <a:lstStyle/>
+          <a:p>
+            <a:pPr marL="0" indent="0">
+              <a:buNone/>
+            </a:pPr>
+            <a:r>
+              <a:rPr lang="en-US" sz="1750" dirty="0">
+                <a:solidFill>
+                  <a:srgbClr val="1D2733"/>
+                </a:solidFill>
+              </a:rPr>
+              <a:t>A.  Near ω=0</a:t>
+            </a:r>
+            <a:endParaRPr lang="en-US" sz="1750" dirty="0"/>
+          </a:p>
+        </p:txBody>
+      </p:sp>
+      <p:sp>
+        <p:nvSpPr>
+          <p:cNvPr id="9" name="Shape 7"/>
+          <p:cNvSpPr/>
+          <p:nvPr/>
+        </p:nvSpPr>
+        <p:spPr>
+          <a:xfrm>
+            <a:off x="960120" y="2953512"/>
+            <a:ext cx="10195560" cy="502920"/>
+          </a:xfrm>
+          <a:prstGeom prst="roundRect">
+            <a:avLst>
+              <a:gd name="adj" fmla="val 7273"/>
+            </a:avLst>
+          </a:prstGeom>
+          <a:solidFill>
+            <a:srgbClr val="F4F7FA"/>
+          </a:solidFill>
+          <a:ln w="12700">
+            <a:solidFill>
+              <a:srgbClr val="DCE4EA"/>
+            </a:solidFill>
+            <a:prstDash val="solid"/>
+          </a:ln>
+        </p:spPr>
+        <p:txBody>
+          <a:bodyPr/>
+          <a:lstStyle/>
+          <a:p>
+            <a:endParaRPr lang="en-US"/>
+          </a:p>
+        </p:txBody>
+      </p:sp>
+      <p:sp>
+        <p:nvSpPr>
+          <p:cNvPr id="10" name="Text 8"/>
+          <p:cNvSpPr/>
+          <p:nvPr/>
+        </p:nvSpPr>
+        <p:spPr>
+          <a:xfrm>
+            <a:off x="1133856" y="3081528"/>
+            <a:ext cx="9738360" cy="219456"/>
+          </a:xfrm>
+          <a:prstGeom prst="rect">
+            <a:avLst/>
+          </a:prstGeom>
+          <a:noFill/>
+          <a:ln/>
+        </p:spPr>
+        <p:txBody>
+          <a:bodyPr wrap="square" lIns="0" tIns="0" rIns="0" bIns="0" rtlCol="0" anchor="ctr"/>
+          <a:lstStyle/>
+          <a:p>
+            <a:pPr marL="0" indent="0">
+              <a:buNone/>
+            </a:pPr>
+            <a:r>
+              <a:rPr lang="en-US" sz="1750" dirty="0">
+                <a:solidFill>
+                  <a:srgbClr val="1D2733"/>
+                </a:solidFill>
+              </a:rPr>
+              <a:t>B.  Near ω=π/2</a:t>
+            </a:r>
+            <a:endParaRPr lang="en-US" sz="1750" dirty="0"/>
+          </a:p>
+        </p:txBody>
+      </p:sp>
+      <p:sp>
+        <p:nvSpPr>
+          <p:cNvPr id="11" name="Shape 9"/>
+          <p:cNvSpPr/>
+          <p:nvPr/>
+        </p:nvSpPr>
+        <p:spPr>
+          <a:xfrm>
+            <a:off x="960120" y="3666744"/>
+            <a:ext cx="10195560" cy="502920"/>
+          </a:xfrm>
+          <a:prstGeom prst="roundRect">
+            <a:avLst>
+              <a:gd name="adj" fmla="val 7273"/>
+            </a:avLst>
+          </a:prstGeom>
+          <a:solidFill>
+            <a:srgbClr val="F4F7FA"/>
+          </a:solidFill>
+          <a:ln w="12700">
+            <a:solidFill>
+              <a:srgbClr val="DCE4EA"/>
+            </a:solidFill>
+            <a:prstDash val="solid"/>
+          </a:ln>
+        </p:spPr>
+        <p:txBody>
+          <a:bodyPr/>
+          <a:lstStyle/>
+          <a:p>
+            <a:endParaRPr lang="en-US"/>
+          </a:p>
+        </p:txBody>
+      </p:sp>
+      <p:sp>
+        <p:nvSpPr>
+          <p:cNvPr id="12" name="Text 10"/>
+          <p:cNvSpPr/>
+          <p:nvPr/>
+        </p:nvSpPr>
+        <p:spPr>
+          <a:xfrm>
+            <a:off x="1133856" y="3794760"/>
+            <a:ext cx="9738360" cy="219456"/>
+          </a:xfrm>
+          <a:prstGeom prst="rect">
+            <a:avLst/>
+          </a:prstGeom>
+          <a:noFill/>
+          <a:ln/>
+        </p:spPr>
+        <p:txBody>
+          <a:bodyPr wrap="square" lIns="0" tIns="0" rIns="0" bIns="0" rtlCol="0" anchor="ctr"/>
+          <a:lstStyle/>
+          <a:p>
+            <a:pPr marL="0" indent="0">
+              <a:buNone/>
+            </a:pPr>
+            <a:r>
+              <a:rPr lang="en-US" sz="1750" dirty="0">
+                <a:solidFill>
+                  <a:srgbClr val="1D2733"/>
+                </a:solidFill>
+              </a:rPr>
+              <a:t>C.  Near ω=π</a:t>
+            </a:r>
+            <a:endParaRPr lang="en-US" sz="1750" dirty="0"/>
+          </a:p>
+        </p:txBody>
+      </p:sp>
+      <p:sp>
+        <p:nvSpPr>
+          <p:cNvPr id="13" name="Shape 11"/>
+          <p:cNvSpPr/>
+          <p:nvPr/>
+        </p:nvSpPr>
+        <p:spPr>
+          <a:xfrm>
+            <a:off x="960120" y="4379976"/>
+            <a:ext cx="10195560" cy="502920"/>
+          </a:xfrm>
+          <a:prstGeom prst="roundRect">
+            <a:avLst>
+              <a:gd name="adj" fmla="val 7273"/>
+            </a:avLst>
+          </a:prstGeom>
+          <a:solidFill>
+            <a:srgbClr val="F4F7FA"/>
+          </a:solidFill>
+          <a:ln w="12700">
+            <a:solidFill>
+              <a:srgbClr val="DCE4EA"/>
+            </a:solidFill>
+            <a:prstDash val="solid"/>
+          </a:ln>
+        </p:spPr>
+        <p:txBody>
+          <a:bodyPr/>
+          <a:lstStyle/>
+          <a:p>
+            <a:endParaRPr lang="en-US"/>
+          </a:p>
+        </p:txBody>
+      </p:sp>
+      <p:sp>
+        <p:nvSpPr>
+          <p:cNvPr id="14" name="Text 12"/>
+          <p:cNvSpPr/>
+          <p:nvPr/>
+        </p:nvSpPr>
+        <p:spPr>
+          <a:xfrm>
+            <a:off x="1133856" y="4507992"/>
+            <a:ext cx="9738360" cy="219456"/>
+          </a:xfrm>
+          <a:prstGeom prst="rect">
+            <a:avLst/>
+          </a:prstGeom>
+          <a:noFill/>
+          <a:ln/>
+        </p:spPr>
+        <p:txBody>
+          <a:bodyPr wrap="square" lIns="0" tIns="0" rIns="0" bIns="0" rtlCol="0" anchor="ctr"/>
+          <a:lstStyle/>
+          <a:p>
+            <a:pPr marL="0" indent="0">
+              <a:buNone/>
+            </a:pPr>
+            <a:r>
+              <a:rPr lang="en-US" sz="1750" dirty="0">
+                <a:solidFill>
+                  <a:srgbClr val="1D2733"/>
+                </a:solidFill>
+              </a:rPr>
+              <a:t>D.  It is constant for all ω</a:t>
+            </a:r>
+            <a:endParaRPr lang="en-US" sz="1750" dirty="0"/>
+          </a:p>
+        </p:txBody>
+      </p:sp>
+      <p:sp>
+        <p:nvSpPr>
+          <p:cNvPr id="25" name="Slide Number Placeholder 0"/>
+          <p:cNvSpPr>
+            <a:spLocks noGrp="1"/>
+          </p:cNvSpPr>
+          <p:nvPr>
+            <p:ph type="sldNum" sz="quarter" idx="4294967295"/>
+          </p:nvPr>
+        </p:nvSpPr>
+        <p:spPr>
+          <a:xfrm>
+            <a:off x="11740896" y="6492240"/>
+            <a:ext cx="228600" cy="164592"/>
+          </a:xfrm>
+          <a:prstGeom prst="rect">
+            <a:avLst/>
+          </a:prstGeom>
+          <a:extLst>
+            <a:ext uri="{C572A759-6A51-4108-AA02-DFA0A04FC94B}">
+              <ma14:wrappingTextBoxFlag xmlns:ma14="http://schemas.microsoft.com/office/mac/drawingml/2011/main" xmlns="" val="0"/>
+            </a:ext>
+          </a:extLst>
+        </p:spPr>
+        <p:txBody>
+          <a:bodyPr/>
+          <a:lstStyle>
+            <a:lvl1pPr>
+              <a:defRPr sz="900">
+                <a:solidFill>
+                  <a:srgbClr val="5C6873"/>
+                </a:solidFill>
+                <a:latin typeface="Aptos"/>
+                <a:ea typeface="Aptos"/>
+                <a:cs typeface="Aptos"/>
+              </a:defRPr>
+            </a:lvl1pPr>
+          </a:lstStyle>
+          <a:p>
+            <a:pPr algn="r"/>
+            <a:fld id="{F7021451-1387-4CA6-816F-3879F97B5CBC}" type="slidenum">
+              <a:rPr lang="en-US" b="0"/>
+              <a:t>20</a:t>
+            </a:fld>
+            <a:endParaRPr lang="en-US"/>
+          </a:p>
+        </p:txBody>
+      </p:sp>
+    </p:spTree>
+  </p:cSld>
+  <p:clrMapOvr>
+    <a:masterClrMapping/>
+  </p:clrMapOvr>
+</p:sld>
+</file>
+
+<file path=ppt/slides/slide21.xml><?xml version="1.0" encoding="utf-8"?>
+<p:sld xmlns:a="http://schemas.openxmlformats.org/drawingml/2006/main" xmlns:r="http://schemas.openxmlformats.org/officeDocument/2006/relationships" xmlns:p="http://schemas.openxmlformats.org/presentationml/2006/main">
+  <p:cSld>
+    <p:spTree>
+      <p:nvGrpSpPr>
+        <p:cNvPr id="1" name="">
+          <a:extLst>
+            <a:ext uri="{FF2B5EF4-FFF2-40B4-BE49-F238E27FC236}">
+              <a16:creationId xmlns:a16="http://schemas.microsoft.com/office/drawing/2014/main" id="{419FED92-AC9C-1AEE-6F1B-6AE66E9DBE99}"/>
+            </a:ext>
+          </a:extLst>
+        </p:cNvPr>
+        <p:cNvGrpSpPr/>
+        <p:nvPr/>
+      </p:nvGrpSpPr>
+      <p:grpSpPr>
+        <a:xfrm>
+          <a:off x="0" y="0"/>
+          <a:ext cx="0" cy="0"/>
+          <a:chOff x="0" y="0"/>
+          <a:chExt cx="0" cy="0"/>
+        </a:xfrm>
+      </p:grpSpPr>
+      <p:sp>
+        <p:nvSpPr>
+          <p:cNvPr id="2" name="Text 0">
+            <a:extLst>
+              <a:ext uri="{FF2B5EF4-FFF2-40B4-BE49-F238E27FC236}">
+                <a16:creationId xmlns:a16="http://schemas.microsoft.com/office/drawing/2014/main" id="{1C8281BD-4A9C-1ED7-9A2E-391F6C3B607F}"/>
+              </a:ext>
+            </a:extLst>
+          </p:cNvPr>
+          <p:cNvSpPr/>
+          <p:nvPr/>
+        </p:nvSpPr>
+        <p:spPr>
+          <a:xfrm>
+            <a:off x="566928" y="347472"/>
+            <a:ext cx="11018520" cy="438912"/>
+          </a:xfrm>
+          <a:prstGeom prst="rect">
+            <a:avLst/>
+          </a:prstGeom>
+          <a:noFill/>
+          <a:ln/>
+        </p:spPr>
+        <p:txBody>
+          <a:bodyPr wrap="square" lIns="0" tIns="0" rIns="0" bIns="0" rtlCol="0" anchor="ctr"/>
+          <a:lstStyle/>
+          <a:p>
+            <a:pPr marL="0" indent="0">
+              <a:buNone/>
+            </a:pPr>
+            <a:r>
+              <a:rPr lang="en-US" sz="2800" b="1" dirty="0">
+                <a:solidFill>
+                  <a:srgbClr val="17324D"/>
+                </a:solidFill>
+                <a:latin typeface="Aptos Display" pitchFamily="34" charset="0"/>
+                <a:ea typeface="Aptos Display" pitchFamily="34" charset="-122"/>
+                <a:cs typeface="Aptos Display" pitchFamily="34" charset="-120"/>
+              </a:rPr>
+              <a:t>Concept check</a:t>
+            </a:r>
+            <a:endParaRPr lang="en-US" sz="2800" dirty="0"/>
+          </a:p>
+        </p:txBody>
+      </p:sp>
+      <p:sp>
+        <p:nvSpPr>
+          <p:cNvPr id="3" name="Text 1">
+            <a:extLst>
+              <a:ext uri="{FF2B5EF4-FFF2-40B4-BE49-F238E27FC236}">
+                <a16:creationId xmlns:a16="http://schemas.microsoft.com/office/drawing/2014/main" id="{3BF39C57-445E-1CE3-6162-D3FAB1DDE9A2}"/>
+              </a:ext>
+            </a:extLst>
+          </p:cNvPr>
+          <p:cNvSpPr/>
+          <p:nvPr/>
+        </p:nvSpPr>
+        <p:spPr>
+          <a:xfrm>
+            <a:off x="585216" y="822960"/>
+            <a:ext cx="10789920" cy="292608"/>
+          </a:xfrm>
+          <a:prstGeom prst="rect">
+            <a:avLst/>
+          </a:prstGeom>
+          <a:noFill/>
+          <a:ln/>
+        </p:spPr>
+        <p:txBody>
+          <a:bodyPr wrap="square" lIns="0" tIns="0" rIns="0" bIns="0" rtlCol="0" anchor="ctr"/>
+          <a:lstStyle/>
+          <a:p>
+            <a:pPr marL="0" indent="0">
+              <a:buNone/>
+            </a:pPr>
+            <a:r>
+              <a:rPr lang="en-US" sz="1400" dirty="0">
+                <a:solidFill>
+                  <a:srgbClr val="5C6873"/>
+                </a:solidFill>
+              </a:rPr>
+              <a:t>Reason from the denominator, not from memorized filter labels.</a:t>
+            </a:r>
+            <a:endParaRPr lang="en-US" sz="1400" dirty="0"/>
+          </a:p>
+        </p:txBody>
+      </p:sp>
+      <p:sp>
+        <p:nvSpPr>
+          <p:cNvPr id="4" name="Shape 2">
+            <a:extLst>
+              <a:ext uri="{FF2B5EF4-FFF2-40B4-BE49-F238E27FC236}">
+                <a16:creationId xmlns:a16="http://schemas.microsoft.com/office/drawing/2014/main" id="{470E304C-C62C-98FC-BC70-1A6E4F5C49C0}"/>
+              </a:ext>
+            </a:extLst>
+          </p:cNvPr>
+          <p:cNvSpPr/>
+          <p:nvPr/>
+        </p:nvSpPr>
+        <p:spPr>
+          <a:xfrm>
+            <a:off x="9966960" y="329184"/>
+            <a:ext cx="1627632" cy="310896"/>
+          </a:xfrm>
+          <a:prstGeom prst="roundRect">
+            <a:avLst>
+              <a:gd name="adj" fmla="val 23529"/>
+            </a:avLst>
+          </a:prstGeom>
+          <a:solidFill>
+            <a:srgbClr val="1F7A8C"/>
+          </a:solidFill>
+          <a:ln w="12700">
+            <a:solidFill>
+              <a:srgbClr val="1F7A8C"/>
+            </a:solidFill>
+            <a:prstDash val="solid"/>
+          </a:ln>
+        </p:spPr>
+        <p:txBody>
+          <a:bodyPr/>
+          <a:lstStyle/>
+          <a:p>
+            <a:endParaRPr lang="en-US"/>
+          </a:p>
+        </p:txBody>
+      </p:sp>
+      <p:sp>
+        <p:nvSpPr>
+          <p:cNvPr id="5" name="Text 3">
+            <a:extLst>
+              <a:ext uri="{FF2B5EF4-FFF2-40B4-BE49-F238E27FC236}">
+                <a16:creationId xmlns:a16="http://schemas.microsoft.com/office/drawing/2014/main" id="{D2A3F664-B844-994C-C24D-7D057FFAD40E}"/>
+              </a:ext>
+            </a:extLst>
+          </p:cNvPr>
+          <p:cNvSpPr/>
+          <p:nvPr/>
+        </p:nvSpPr>
+        <p:spPr>
+          <a:xfrm>
+            <a:off x="10012680" y="393192"/>
+            <a:ext cx="1527048" cy="146304"/>
+          </a:xfrm>
+          <a:prstGeom prst="rect">
+            <a:avLst/>
+          </a:prstGeom>
+          <a:noFill/>
+          <a:ln/>
+        </p:spPr>
+        <p:txBody>
+          <a:bodyPr wrap="square" lIns="0" tIns="0" rIns="0" bIns="0" rtlCol="0" anchor="ctr"/>
+          <a:lstStyle/>
+          <a:p>
+            <a:pPr marL="0" indent="0" algn="ctr">
+              <a:buNone/>
+            </a:pPr>
+            <a:r>
+              <a:rPr lang="en-US" sz="900" b="1" kern="0" spc="60" dirty="0">
+                <a:solidFill>
+                  <a:srgbClr val="FFFFFF"/>
+                </a:solidFill>
+              </a:rPr>
+              <a:t>CHECK</a:t>
+            </a:r>
+            <a:endParaRPr lang="en-US" sz="900" dirty="0"/>
+          </a:p>
+        </p:txBody>
+      </p:sp>
+      <p:sp>
+        <p:nvSpPr>
+          <p:cNvPr id="6" name="Text 4">
+            <a:extLst>
+              <a:ext uri="{FF2B5EF4-FFF2-40B4-BE49-F238E27FC236}">
+                <a16:creationId xmlns:a16="http://schemas.microsoft.com/office/drawing/2014/main" id="{795A1BBD-E0FB-221F-2DE8-6A4F1FD5C7F7}"/>
+              </a:ext>
+            </a:extLst>
+          </p:cNvPr>
+          <p:cNvSpPr/>
+          <p:nvPr/>
+        </p:nvSpPr>
+        <p:spPr>
+          <a:xfrm>
+            <a:off x="731520" y="1325880"/>
+            <a:ext cx="10744200" cy="731520"/>
+          </a:xfrm>
+          <a:prstGeom prst="rect">
+            <a:avLst/>
+          </a:prstGeom>
+          <a:noFill/>
+          <a:ln/>
+        </p:spPr>
+        <p:txBody>
+          <a:bodyPr wrap="square" lIns="254" tIns="254" rIns="254" bIns="254" rtlCol="0" anchor="ctr">
+            <a:normAutofit/>
+          </a:bodyPr>
+          <a:lstStyle/>
+          <a:p>
+            <a:pPr marL="0" indent="0">
+              <a:buNone/>
+            </a:pPr>
+            <a:r>
+              <a:rPr lang="en-US" sz="2300" b="1" dirty="0">
+                <a:solidFill>
+                  <a:srgbClr val="1D2733"/>
+                </a:solidFill>
+              </a:rPr>
+              <a:t>For H(e^{jω}) = 1/(1 − 0.9e^{−jω}), where is |H| largest?</a:t>
+            </a:r>
+            <a:endParaRPr lang="en-US" sz="2300" dirty="0"/>
+          </a:p>
+        </p:txBody>
+      </p:sp>
+      <p:sp>
+        <p:nvSpPr>
+          <p:cNvPr id="7" name="Shape 5">
+            <a:extLst>
+              <a:ext uri="{FF2B5EF4-FFF2-40B4-BE49-F238E27FC236}">
+                <a16:creationId xmlns:a16="http://schemas.microsoft.com/office/drawing/2014/main" id="{D678D3B0-994B-05D4-EDE4-B9DEA9D168AF}"/>
+              </a:ext>
+            </a:extLst>
+          </p:cNvPr>
           <p:cNvSpPr/>
           <p:nvPr/>
         </p:nvSpPr>
@@ -10865,7 +11562,13 @@
       </p:sp>
       <p:sp>
         <p:nvSpPr>
-          <p:cNvPr id="8" name="Text 6"/>
+          <p:cNvPr id="8" name="Text 6">
+            <a:extLst>
+              <a:ext uri="{FF2B5EF4-FFF2-40B4-BE49-F238E27FC236}">
+                <a16:creationId xmlns:a16="http://schemas.microsoft.com/office/drawing/2014/main" id="{1E6C6FC0-5E15-7F2F-CCE2-F8D120C8945F}"/>
+              </a:ext>
+            </a:extLst>
+          </p:cNvPr>
           <p:cNvSpPr/>
           <p:nvPr/>
         </p:nvSpPr>
@@ -10901,7 +11604,13 @@
       </p:sp>
       <p:sp>
         <p:nvSpPr>
-          <p:cNvPr id="9" name="Shape 7"/>
+          <p:cNvPr id="9" name="Shape 7">
+            <a:extLst>
+              <a:ext uri="{FF2B5EF4-FFF2-40B4-BE49-F238E27FC236}">
+                <a16:creationId xmlns:a16="http://schemas.microsoft.com/office/drawing/2014/main" id="{BD27E65A-D20A-D16E-F68F-D7EA1ED28A1C}"/>
+              </a:ext>
+            </a:extLst>
+          </p:cNvPr>
           <p:cNvSpPr/>
           <p:nvPr/>
         </p:nvSpPr>
@@ -10935,7 +11644,13 @@
       </p:sp>
       <p:sp>
         <p:nvSpPr>
-          <p:cNvPr id="10" name="Text 8"/>
+          <p:cNvPr id="10" name="Text 8">
+            <a:extLst>
+              <a:ext uri="{FF2B5EF4-FFF2-40B4-BE49-F238E27FC236}">
+                <a16:creationId xmlns:a16="http://schemas.microsoft.com/office/drawing/2014/main" id="{51655AF5-3B82-714B-5E1E-4F4F5AE90126}"/>
+              </a:ext>
+            </a:extLst>
+          </p:cNvPr>
           <p:cNvSpPr/>
           <p:nvPr/>
         </p:nvSpPr>
@@ -10971,7 +11686,13 @@
       </p:sp>
       <p:sp>
         <p:nvSpPr>
-          <p:cNvPr id="11" name="Shape 9"/>
+          <p:cNvPr id="11" name="Shape 9">
+            <a:extLst>
+              <a:ext uri="{FF2B5EF4-FFF2-40B4-BE49-F238E27FC236}">
+                <a16:creationId xmlns:a16="http://schemas.microsoft.com/office/drawing/2014/main" id="{39B08BE5-F7A1-EB8B-803E-7878257F69DE}"/>
+              </a:ext>
+            </a:extLst>
+          </p:cNvPr>
           <p:cNvSpPr/>
           <p:nvPr/>
         </p:nvSpPr>
@@ -11005,7 +11726,13 @@
       </p:sp>
       <p:sp>
         <p:nvSpPr>
-          <p:cNvPr id="12" name="Text 10"/>
+          <p:cNvPr id="12" name="Text 10">
+            <a:extLst>
+              <a:ext uri="{FF2B5EF4-FFF2-40B4-BE49-F238E27FC236}">
+                <a16:creationId xmlns:a16="http://schemas.microsoft.com/office/drawing/2014/main" id="{5322E073-D23E-9017-0CC6-BBAE60317DE2}"/>
+              </a:ext>
+            </a:extLst>
+          </p:cNvPr>
           <p:cNvSpPr/>
           <p:nvPr/>
         </p:nvSpPr>
@@ -11041,7 +11768,13 @@
       </p:sp>
       <p:sp>
         <p:nvSpPr>
-          <p:cNvPr id="13" name="Shape 11"/>
+          <p:cNvPr id="13" name="Shape 11">
+            <a:extLst>
+              <a:ext uri="{FF2B5EF4-FFF2-40B4-BE49-F238E27FC236}">
+                <a16:creationId xmlns:a16="http://schemas.microsoft.com/office/drawing/2014/main" id="{767A24A4-087E-4663-2F8B-45BCD7087EDF}"/>
+              </a:ext>
+            </a:extLst>
+          </p:cNvPr>
           <p:cNvSpPr/>
           <p:nvPr/>
         </p:nvSpPr>
@@ -11075,7 +11808,13 @@
       </p:sp>
       <p:sp>
         <p:nvSpPr>
-          <p:cNvPr id="14" name="Text 12"/>
+          <p:cNvPr id="14" name="Text 12">
+            <a:extLst>
+              <a:ext uri="{FF2B5EF4-FFF2-40B4-BE49-F238E27FC236}">
+                <a16:creationId xmlns:a16="http://schemas.microsoft.com/office/drawing/2014/main" id="{D702289E-C913-8984-1231-D70AE6E7EEA6}"/>
+              </a:ext>
+            </a:extLst>
+          </p:cNvPr>
           <p:cNvSpPr/>
           <p:nvPr/>
         </p:nvSpPr>
@@ -11111,7 +11850,13 @@
       </p:sp>
       <p:sp>
         <p:nvSpPr>
-          <p:cNvPr id="15" name="Text 13"/>
+          <p:cNvPr id="15" name="Text 13">
+            <a:extLst>
+              <a:ext uri="{FF2B5EF4-FFF2-40B4-BE49-F238E27FC236}">
+                <a16:creationId xmlns:a16="http://schemas.microsoft.com/office/drawing/2014/main" id="{D27CC499-F737-0805-B7E9-E3EF2C7D0502}"/>
+              </a:ext>
+            </a:extLst>
+          </p:cNvPr>
           <p:cNvSpPr/>
           <p:nvPr/>
         </p:nvSpPr>
@@ -11149,7 +11894,13 @@
       </p:sp>
       <p:sp>
         <p:nvSpPr>
-          <p:cNvPr id="25" name="Slide Number Placeholder 0"/>
+          <p:cNvPr id="25" name="Slide Number Placeholder 0">
+            <a:extLst>
+              <a:ext uri="{FF2B5EF4-FFF2-40B4-BE49-F238E27FC236}">
+                <a16:creationId xmlns:a16="http://schemas.microsoft.com/office/drawing/2014/main" id="{5483B98D-17BF-212E-6B8B-215109D6256C}"/>
+              </a:ext>
+            </a:extLst>
+          </p:cNvPr>
           <p:cNvSpPr>
             <a:spLocks noGrp="1"/>
           </p:cNvSpPr>
@@ -11167,7 +11918,7 @@
           </a:prstGeom>
           <a:extLst>
             <a:ext uri="{C572A759-6A51-4108-AA02-DFA0A04FC94B}">
-              <ma14:wrappingTextBoxFlag xmlns:ma14="http://schemas.microsoft.com/office/mac/drawingml/2011/main" xmlns="" val="0"/>
+              <ma14:wrappingTextBoxFlag xmlns="" xmlns:ma14="http://schemas.microsoft.com/office/mac/drawingml/2011/main" val="0"/>
             </a:ext>
           </a:extLst>
         </p:spPr>
@@ -11189,13 +11940,18 @@
             <a:pPr algn="r"/>
             <a:fld id="{F7021451-1387-4CA6-816F-3879F97B5CBC}" type="slidenum">
               <a:rPr lang="en-US" b="0"/>
-              <a:t>20</a:t>
+              <a:t>21</a:t>
             </a:fld>
             <a:endParaRPr lang="en-US"/>
           </a:p>
         </p:txBody>
       </p:sp>
     </p:spTree>
+    <p:extLst>
+      <p:ext uri="{BB962C8B-B14F-4D97-AF65-F5344CB8AC3E}">
+        <p14:creationId xmlns:p14="http://schemas.microsoft.com/office/powerpoint/2010/main" val="3238470878"/>
+      </p:ext>
+    </p:extLst>
   </p:cSld>
   <p:clrMapOvr>
     <a:masterClrMapping/>
@@ -11203,7 +11959,7 @@
 </p:sld>
 </file>
 
-<file path=ppt/slides/slide21.xml><?xml version="1.0" encoding="utf-8"?>
+<file path=ppt/slides/slide22.xml><?xml version="1.0" encoding="utf-8"?>
 <p:sld xmlns:a="http://schemas.openxmlformats.org/drawingml/2006/main" xmlns:r="http://schemas.openxmlformats.org/officeDocument/2006/relationships" xmlns:p="http://schemas.openxmlformats.org/presentationml/2006/main">
   <p:cSld name="Slide 21">
     <p:spTree>
@@ -12252,7 +13008,7 @@
             <a:pPr algn="r"/>
             <a:fld id="{F7021451-1387-4CA6-816F-3879F97B5CBC}" type="slidenum">
               <a:rPr lang="en-US" b="0"/>
-              <a:t>21</a:t>
+              <a:t>22</a:t>
             </a:fld>
             <a:endParaRPr lang="en-US"/>
           </a:p>
@@ -12266,7 +13022,7 @@
 </p:sld>
 </file>
 
-<file path=ppt/slides/slide22.xml><?xml version="1.0" encoding="utf-8"?>
+<file path=ppt/slides/slide23.xml><?xml version="1.0" encoding="utf-8"?>
 <p:sld xmlns:a="http://schemas.openxmlformats.org/drawingml/2006/main" xmlns:r="http://schemas.openxmlformats.org/officeDocument/2006/relationships" xmlns:p="http://schemas.openxmlformats.org/presentationml/2006/main">
   <p:cSld name="Slide 22">
     <p:spTree>
@@ -12495,21 +13251,6 @@
             </a:r>
             <a:endParaRPr lang="en-US" sz="2000" dirty="0"/>
           </a:p>
-          <a:p>
-            <a:pPr marL="228600" indent="-228600">
-              <a:buSzPct val="100000"/>
-              <a:buChar char="•"/>
-            </a:pPr>
-            <a:r>
-              <a:rPr lang="en-US" sz="2000" dirty="0">
-                <a:solidFill>
-                  <a:srgbClr val="1D2733"/>
-                </a:solidFill>
-              </a:rPr>
-              <a:t>Solutions are in the accompanying instructor handout.</a:t>
-            </a:r>
-            <a:endParaRPr lang="en-US" sz="2000" dirty="0"/>
-          </a:p>
         </p:txBody>
       </p:sp>
       <p:sp>
@@ -12662,7 +13403,7 @@
             <a:pPr algn="r"/>
             <a:fld id="{F7021451-1387-4CA6-816F-3879F97B5CBC}" type="slidenum">
               <a:rPr lang="en-US" b="0"/>
-              <a:t>22</a:t>
+              <a:t>23</a:t>
             </a:fld>
             <a:endParaRPr lang="en-US"/>
           </a:p>

</xml_diff>